<commit_message>
fix(explainer): do not cache LLM fallbacks; regenerate slides with LLM active
</commit_message>
<xml_diff>
--- a/consegna/EnerGuard_Presentazione.pptx
+++ b/consegna/EnerGuard_Presentazione.pptx
@@ -9418,8 +9418,8 @@
         </p:blipFill>
         <p:spPr>
           <a:xfrm>
-            <a:off x="924098" y="1234440"/>
-            <a:ext cx="6107083" cy="5303520"/>
+            <a:off x="696858" y="1234440"/>
+            <a:ext cx="6561564" cy="5303520"/>
           </a:xfrm>
           <a:prstGeom prst="rect">
             <a:avLst/>
@@ -9674,7 +9674,23 @@
                   <a:srgbClr val="0B1F3A"/>
                 </a:solidFill>
               </a:rPr>
-              <a:t>Nello screenshot l'LLM non era raggiungibile: la card resta spiegata e la fonte dice </a:t>
+              <a:t>Fonte dichiarata: </a:t>
+            </a:r>
+            <a:r>
+              <a:rPr sz="1600" b="1">
+                <a:solidFill>
+                  <a:srgbClr val="0B1F3A"/>
+                </a:solidFill>
+              </a:rPr>
+              <a:t>llm:azure/gpt-5.6-luna</a:t>
+            </a:r>
+            <a:r>
+              <a:rPr sz="1600" b="0">
+                <a:solidFill>
+                  <a:srgbClr val="0B1F3A"/>
+                </a:solidFill>
+              </a:rPr>
+              <a:t>, circa 2 s. Senza rete la card resta spiegata con </a:t>
             </a:r>
             <a:r>
               <a:rPr sz="1600" b="1">

</xml_diff>

<commit_message>
docs(consegna): slides with real review history and reviewer-behaviour slide
</commit_message>
<xml_diff>
--- a/consegna/EnerGuard_Presentazione.pptx
+++ b/consegna/EnerGuard_Presentazione.pptx
@@ -20,6 +20,7 @@
     <p:sldId id="268" r:id="rId20"/>
     <p:sldId id="269" r:id="rId21"/>
     <p:sldId id="270" r:id="rId22"/>
+    <p:sldId id="271" r:id="rId23"/>
   </p:sldIdLst>
   <p:sldSz cx="12191695" cy="6858000" type="screen4x3"/>
   <p:notesSz cx="6858000" cy="9144000"/>
@@ -796,7 +797,7 @@
           <a:lstStyle/>
           <a:p>
             <a:r>
-              <a:t>Un limite dichiarato vale più di uno scoperto. Elenco completo nell'allegato della relazione d'impatto.</a:t>
+              <a:t>Un sistema di oversight che non misura la propria supervisione non è supervisionabile. Ma attenzione: misurare i revisori è anche controllo dei lavoratori.</a:t>
             </a:r>
           </a:p>
         </p:txBody>
@@ -866,7 +867,7 @@
           <a:lstStyle/>
           <a:p>
             <a:r>
-              <a:t>Domanda finale della guida: chi è provider e chi deployer. Poi alcuni spunti che non hanno una risposta unica.</a:t>
+              <a:t>Un limite dichiarato vale più di uno scoperto. Elenco completo nell'allegato della relazione d'impatto.</a:t>
             </a:r>
           </a:p>
         </p:txBody>
@@ -892,6 +893,76 @@
 </file>
 
 <file path=ppt/notesSlides/notesSlide15.xml><?xml version="1.0" encoding="utf-8"?>
+<p:notes xmlns:a="http://schemas.openxmlformats.org/drawingml/2006/main" xmlns:p="http://schemas.openxmlformats.org/presentationml/2006/main" xmlns:r="http://schemas.openxmlformats.org/officeDocument/2006/relationships">
+  <p:cSld>
+    <p:spTree>
+      <p:nvGrpSpPr>
+        <p:cNvPr id="1" name=""/>
+        <p:cNvGrpSpPr/>
+        <p:nvPr/>
+      </p:nvGrpSpPr>
+      <p:grpSpPr>
+        <a:xfrm>
+          <a:off x="0" y="0"/>
+          <a:ext cx="0" cy="0"/>
+          <a:chOff x="0" y="0"/>
+          <a:chExt cx="0" cy="0"/>
+        </a:xfrm>
+      </p:grpSpPr>
+      <p:sp>
+        <p:nvSpPr>
+          <p:cNvPr id="2" name="Slide Image Placeholder 1"/>
+          <p:cNvSpPr>
+            <a:spLocks noGrp="1"/>
+          </p:cNvSpPr>
+          <p:nvPr>
+            <p:ph type="sldImg" idx="2"/>
+          </p:nvPr>
+        </p:nvSpPr>
+        <p:spPr/>
+      </p:sp>
+      <p:sp>
+        <p:nvSpPr>
+          <p:cNvPr id="3" name="Notes Placeholder 2"/>
+          <p:cNvSpPr>
+            <a:spLocks noGrp="1"/>
+          </p:cNvSpPr>
+          <p:nvPr>
+            <p:ph type="body" idx="3" sz="quarter"/>
+          </p:nvPr>
+        </p:nvSpPr>
+        <p:spPr/>
+        <p:txBody>
+          <a:bodyPr/>
+          <a:lstStyle/>
+          <a:p>
+            <a:r>
+              <a:t>Domanda finale della guida: chi è provider e chi deployer. Poi alcuni spunti che non hanno una risposta unica.</a:t>
+            </a:r>
+          </a:p>
+        </p:txBody>
+      </p:sp>
+      <p:sp>
+        <p:nvSpPr>
+          <p:cNvPr id="4" name="Slide Number Placeholder 3"/>
+          <p:cNvSpPr>
+            <a:spLocks noGrp="1"/>
+          </p:cNvSpPr>
+          <p:nvPr>
+            <p:ph type="sldNum" idx="5" sz="quarter"/>
+          </p:nvPr>
+        </p:nvSpPr>
+        <p:spPr/>
+      </p:sp>
+    </p:spTree>
+  </p:cSld>
+  <p:clrMapOvr>
+    <a:masterClrMapping/>
+  </p:clrMapOvr>
+</p:notes>
+</file>
+
+<file path=ppt/notesSlides/notesSlide16.xml><?xml version="1.0" encoding="utf-8"?>
 <p:notes xmlns:a="http://schemas.openxmlformats.org/drawingml/2006/main" xmlns:p="http://schemas.openxmlformats.org/presentationml/2006/main" xmlns:r="http://schemas.openxmlformats.org/officeDocument/2006/relationships">
   <p:cSld>
     <p:spTree>
@@ -5892,7 +5963,7 @@
                   <a:srgbClr val="555F6D"/>
                 </a:solidFill>
               </a:rPr>
-              <a:t>Screenshot a sessione appena avviata: i KPI sulle revisioni (A2-A4) sono n/d finché nessuno decide.</a:t>
+              <a:t>Dati reali: 17 revisioni di 3 operatori. A3 oltre target perché misura anche l'attesa in coda; B3c conta le risposte LLM scartate dai guardrail.</a:t>
             </a:r>
           </a:p>
         </p:txBody>
@@ -5991,7 +6062,7 @@
                   <a:srgbClr val="FFFFFF"/>
                 </a:solidFill>
               </a:rPr>
-              <a:t>Cosa NON abbiamo risolto</a:t>
+              <a:t>Chi controlla i controllori</a:t>
             </a:r>
           </a:p>
         </p:txBody>
@@ -6029,7 +6100,7 @@
                   <a:srgbClr val="C9D8EA"/>
                 </a:solidFill>
               </a:rPr>
-              <a:t>10% del punteggio</a:t>
+              <a:t>Art. 14(4)(b) · A2-A4 · C3</a:t>
             </a:r>
           </a:p>
         </p:txBody>
@@ -6077,16 +6148,74 @@
           </a:p>
         </p:txBody>
       </p:sp>
-      <p:sp>
-        <p:nvSpPr>
-          <p:cNvPr id="6" name="TextBox 5"/>
+      <p:pic>
+        <p:nvPicPr>
+          <p:cNvPr id="6" name="Picture 5" descr="kpi_3.png"/>
+          <p:cNvPicPr>
+            <a:picLocks noChangeAspect="1"/>
+          </p:cNvPicPr>
+          <p:nvPr/>
+        </p:nvPicPr>
+        <p:blipFill>
+          <a:blip r:embed="rId2"/>
+          <a:stretch>
+            <a:fillRect/>
+          </a:stretch>
+        </p:blipFill>
+        <p:spPr>
+          <a:xfrm>
+            <a:off x="365760" y="1234440"/>
+            <a:ext cx="5760720" cy="2014086"/>
+          </a:xfrm>
+          <a:prstGeom prst="rect">
+            <a:avLst/>
+          </a:prstGeom>
+          <a:ln w="12700">
+            <a:solidFill>
+              <a:srgbClr val="D0D5DD"/>
+            </a:solidFill>
+          </a:ln>
+        </p:spPr>
+      </p:pic>
+      <p:pic>
+        <p:nvPicPr>
+          <p:cNvPr id="7" name="Picture 6" descr="bias_5.png"/>
+          <p:cNvPicPr>
+            <a:picLocks noChangeAspect="1"/>
+          </p:cNvPicPr>
+          <p:nvPr/>
+        </p:nvPicPr>
+        <p:blipFill>
+          <a:blip r:embed="rId3"/>
+          <a:stretch>
+            <a:fillRect/>
+          </a:stretch>
+        </p:blipFill>
+        <p:spPr>
+          <a:xfrm>
+            <a:off x="373320" y="3840480"/>
+            <a:ext cx="5745600" cy="1828800"/>
+          </a:xfrm>
+          <a:prstGeom prst="rect">
+            <a:avLst/>
+          </a:prstGeom>
+          <a:ln w="12700">
+            <a:solidFill>
+              <a:srgbClr val="D0D5DD"/>
+            </a:solidFill>
+          </a:ln>
+        </p:spPr>
+      </p:pic>
+      <p:sp>
+        <p:nvSpPr>
+          <p:cNvPr id="8" name="TextBox 7"/>
           <p:cNvSpPr txBox="1"/>
           <p:nvPr/>
         </p:nvSpPr>
         <p:spPr>
           <a:xfrm>
-            <a:off x="548640" y="1280160"/>
-            <a:ext cx="11064240" cy="5303520"/>
+            <a:off x="6400800" y="1280160"/>
+            <a:ext cx="5394960" cy="5303520"/>
           </a:xfrm>
           <a:prstGeom prst="rect">
             <a:avLst/>
@@ -6105,7 +6234,7 @@
               </a:spcAft>
             </a:pPr>
             <a:r>
-              <a:rPr sz="1900" b="1">
+              <a:rPr sz="1600" b="1">
                 <a:solidFill>
                   <a:srgbClr val="0F6CBD"/>
                 </a:solidFill>
@@ -6113,28 +6242,20 @@
               <a:t>•  </a:t>
             </a:r>
             <a:r>
-              <a:rPr sz="1900" b="0">
-                <a:solidFill>
-                  <a:srgbClr val="0B1F3A"/>
-                </a:solidFill>
-              </a:rPr>
-              <a:t>La sotto-segnalazione al Sud è un'</a:t>
-            </a:r>
-            <a:r>
-              <a:rPr sz="1900" b="1">
-                <a:solidFill>
-                  <a:srgbClr val="0B1F3A"/>
-                </a:solidFill>
-              </a:rPr>
-              <a:t>ipotesi</a:t>
-            </a:r>
-            <a:r>
-              <a:rPr sz="1900" b="0">
-                <a:solidFill>
-                  <a:srgbClr val="0B1F3A"/>
-                </a:solidFill>
-              </a:rPr>
-              <a:t>: serve una verifica sul campo.</a:t>
+              <a:rPr sz="1600" b="1">
+                <a:solidFill>
+                  <a:srgbClr val="0B1F3A"/>
+                </a:solidFill>
+              </a:rPr>
+              <a:t>Override 35%</a:t>
+            </a:r>
+            <a:r>
+              <a:rPr sz="1600" b="0">
+                <a:solidFill>
+                  <a:srgbClr val="0B1F3A"/>
+                </a:solidFill>
+              </a:rPr>
+              <a:t>: dentro il target 5-40%, nessun segno di approvazione automatica.</a:t>
             </a:r>
           </a:p>
           <a:p>
@@ -6144,7 +6265,7 @@
               </a:spcAft>
             </a:pPr>
             <a:r>
-              <a:rPr sz="1900" b="1">
+              <a:rPr sz="1600" b="1">
                 <a:solidFill>
                   <a:srgbClr val="0F6CBD"/>
                 </a:solidFill>
@@ -6152,28 +6273,20 @@
               <a:t>•  </a:t>
             </a:r>
             <a:r>
-              <a:rPr sz="1900" b="0">
-                <a:solidFill>
-                  <a:srgbClr val="0B1F3A"/>
-                </a:solidFill>
-              </a:rPr>
-              <a:t>Al Nord e al Centro un guasto su quattro arriva </a:t>
-            </a:r>
-            <a:r>
-              <a:rPr sz="1900" b="1">
-                <a:solidFill>
-                  <a:srgbClr val="0B1F3A"/>
-                </a:solidFill>
-              </a:rPr>
-              <a:t>senza segnali nei sensori</a:t>
-            </a:r>
-            <a:r>
-              <a:rPr sz="1900" b="0">
-                <a:solidFill>
-                  <a:srgbClr val="0B1F3A"/>
-                </a:solidFill>
-              </a:rPr>
-              <a:t>.</a:t>
+              <a:rPr sz="1600" b="1">
+                <a:solidFill>
+                  <a:srgbClr val="0B1F3A"/>
+                </a:solidFill>
+              </a:rPr>
+              <a:t>Per revisore</a:t>
+            </a:r>
+            <a:r>
+              <a:rPr sz="1600" b="0">
+                <a:solidFill>
+                  <a:srgbClr val="0B1F3A"/>
+                </a:solidFill>
+              </a:rPr>
+              <a:t>: OP-031 corregge l'AI più spesso (approva il 40%), OP-022 quasi mai (83%) e ha una motivazione troppo breve.</a:t>
             </a:r>
           </a:p>
           <a:p>
@@ -6183,7 +6296,7 @@
               </a:spcAft>
             </a:pPr>
             <a:r>
-              <a:rPr sz="1900" b="1">
+              <a:rPr sz="1600" b="1">
                 <a:solidFill>
                   <a:srgbClr val="0F6CBD"/>
                 </a:solidFill>
@@ -6191,20 +6304,12 @@
               <a:t>•  </a:t>
             </a:r>
             <a:r>
-              <a:rPr sz="1900" b="1">
-                <a:solidFill>
-                  <a:srgbClr val="0B1F3A"/>
-                </a:solidFill>
-              </a:rPr>
-              <a:t>183 ispezioni inutili</a:t>
-            </a:r>
-            <a:r>
-              <a:rPr sz="1900" b="0">
-                <a:solidFill>
-                  <a:srgbClr val="0B1F3A"/>
-                </a:solidFill>
-              </a:rPr>
-              <a:t> su 720: il prezzo di un recall più alto; costo 10:1 ipotizzato.</a:t>
+              <a:rPr sz="1600" b="0">
+                <a:solidFill>
+                  <a:srgbClr val="0B1F3A"/>
+                </a:solidFill>
+              </a:rPr>
+              <a:t>Dopo tre decisioni di OP-022, una con motivazione breve, l'allerta è scattata davvero; con le successive è rientrata.</a:t>
             </a:r>
           </a:p>
           <a:p>
@@ -6214,7 +6319,7 @@
               </a:spcAft>
             </a:pPr>
             <a:r>
-              <a:rPr sz="1900" b="1">
+              <a:rPr sz="1600" b="1">
                 <a:solidFill>
                   <a:srgbClr val="0F6CBD"/>
                 </a:solidFill>
@@ -6222,28 +6327,20 @@
               <a:t>•  </a:t>
             </a:r>
             <a:r>
-              <a:rPr sz="1900" b="0">
-                <a:solidFill>
-                  <a:srgbClr val="0B1F3A"/>
-                </a:solidFill>
-              </a:rPr>
-              <a:t>La correzione del bias è affidata all'</a:t>
-            </a:r>
-            <a:r>
-              <a:rPr sz="1900" b="1">
-                <a:solidFill>
-                  <a:srgbClr val="0B1F3A"/>
-                </a:solidFill>
-              </a:rPr>
-              <a:t>umano</a:t>
-            </a:r>
-            <a:r>
-              <a:rPr sz="1900" b="0">
-                <a:solidFill>
-                  <a:srgbClr val="0B1F3A"/>
-                </a:solidFill>
-              </a:rPr>
-              <a:t>: se approva tutto, la promozione a HITL serve a poco.</a:t>
+              <a:rPr sz="1600" b="1">
+                <a:solidFill>
+                  <a:srgbClr val="0B1F3A"/>
+                </a:solidFill>
+              </a:rPr>
+              <a:t>Per area</a:t>
+            </a:r>
+            <a:r>
+              <a:rPr sz="1600" b="0">
+                <a:solidFill>
+                  <a:srgbClr val="0B1F3A"/>
+                </a:solidFill>
+              </a:rPr>
+              <a:t>: le Isole hanno override 0.50 contro una media di 0.35; sotto il doppio, quindi nessuna allerta.</a:t>
             </a:r>
           </a:p>
           <a:p>
@@ -6253,7 +6350,7 @@
               </a:spcAft>
             </a:pPr>
             <a:r>
-              <a:rPr sz="1900" b="1">
+              <a:rPr sz="1600" b="1">
                 <a:solidFill>
                   <a:srgbClr val="0F6CBD"/>
                 </a:solidFill>
@@ -6261,106 +6358,28 @@
               <a:t>•  </a:t>
             </a:r>
             <a:r>
-              <a:rPr sz="1900" b="1">
-                <a:solidFill>
-                  <a:srgbClr val="0B1F3A"/>
-                </a:solidFill>
-              </a:rPr>
-              <a:t>Confidenza = max(p, 1−p)</a:t>
-            </a:r>
-            <a:r>
-              <a:rPr sz="1900" b="0">
-                <a:solidFill>
-                  <a:srgbClr val="0B1F3A"/>
-                </a:solidFill>
-              </a:rPr>
-              <a:t>: non aggiunge informazione rispetto alla probabilità.</a:t>
-            </a:r>
-          </a:p>
-          <a:p>
-            <a:pPr>
-              <a:spcAft>
-                <a:spcPts val="800"/>
-              </a:spcAft>
-            </a:pPr>
-            <a:r>
-              <a:rPr sz="1900" b="1">
-                <a:solidFill>
-                  <a:srgbClr val="0F6CBD"/>
-                </a:solidFill>
-              </a:rPr>
-              <a:t>•  </a:t>
-            </a:r>
-            <a:r>
-              <a:rPr sz="1900" b="1">
-                <a:solidFill>
-                  <a:srgbClr val="0B1F3A"/>
-                </a:solidFill>
-              </a:rPr>
-              <a:t>Drift simulato</a:t>
-            </a:r>
-            <a:r>
-              <a:rPr sz="1900" b="0">
-                <a:solidFill>
-                  <a:srgbClr val="0B1F3A"/>
-                </a:solidFill>
-              </a:rPr>
-              <a:t>, revisori non differenziati per competenza, </a:t>
-            </a:r>
-            <a:r>
-              <a:rPr sz="1900" b="1">
-                <a:solidFill>
-                  <a:srgbClr val="0B1F3A"/>
-                </a:solidFill>
-              </a:rPr>
-              <a:t>2 guasti</a:t>
-            </a:r>
-            <a:r>
-              <a:rPr sz="1900" b="0">
-                <a:solidFill>
-                  <a:srgbClr val="0B1F3A"/>
-                </a:solidFill>
-              </a:rPr>
-              <a:t> nelle Isole ancora automatici.</a:t>
-            </a:r>
-          </a:p>
-          <a:p>
-            <a:pPr>
-              <a:spcAft>
-                <a:spcPts val="800"/>
-              </a:spcAft>
-            </a:pPr>
-            <a:r>
-              <a:rPr sz="1900" b="1">
-                <a:solidFill>
-                  <a:srgbClr val="0F6CBD"/>
-                </a:solidFill>
-              </a:rPr>
-              <a:t>•  </a:t>
-            </a:r>
-            <a:r>
-              <a:rPr sz="1900" b="0">
-                <a:solidFill>
-                  <a:srgbClr val="0B1F3A"/>
-                </a:solidFill>
-              </a:rPr>
-              <a:t>Catena di hash </a:t>
-            </a:r>
-            <a:r>
-              <a:rPr sz="1900" b="1">
-                <a:solidFill>
-                  <a:srgbClr val="0B1F3A"/>
-                </a:solidFill>
-              </a:rPr>
-              <a:t>senza chiave</a:t>
-            </a:r>
-            <a:r>
-              <a:rPr sz="1900" b="0">
-                <a:solidFill>
-                  <a:srgbClr val="0B1F3A"/>
-                </a:solidFill>
-              </a:rPr>
-              <a:t>: una riscrittura completa del log non verrebbe rilevata.</a:t>
+              <a:rPr sz="1600" b="0">
+                <a:solidFill>
+                  <a:srgbClr val="0B1F3A"/>
+                </a:solidFill>
+              </a:rPr>
+              <a:t>Queste metriche misurano </a:t>
+            </a:r>
+            <a:r>
+              <a:rPr sz="1600" b="1">
+                <a:solidFill>
+                  <a:srgbClr val="0B1F3A"/>
+                </a:solidFill>
+              </a:rPr>
+              <a:t>persone</a:t>
+            </a:r>
+            <a:r>
+              <a:rPr sz="1600" b="0">
+                <a:solidFill>
+                  <a:srgbClr val="0B1F3A"/>
+                </a:solidFill>
+              </a:rPr>
+              <a:t>: in produzione servono informativa ai lavoratori e regole d'uso chiare.</a:t>
             </a:r>
           </a:p>
         </p:txBody>
@@ -6459,7 +6478,7 @@
                   <a:srgbClr val="FFFFFF"/>
                 </a:solidFill>
               </a:rPr>
-              <a:t>AI Act: ruoli e domande aperte</a:t>
+              <a:t>Cosa NON abbiamo risolto</a:t>
             </a:r>
           </a:p>
         </p:txBody>
@@ -6497,7 +6516,7 @@
                   <a:srgbClr val="C9D8EA"/>
                 </a:solidFill>
               </a:rPr>
-              <a:t>Discussione</a:t>
+              <a:t>10% del punteggio</a:t>
             </a:r>
           </a:p>
         </p:txBody>
@@ -6554,6 +6573,474 @@
         <p:spPr>
           <a:xfrm>
             <a:off x="548640" y="1280160"/>
+            <a:ext cx="11064240" cy="5303520"/>
+          </a:xfrm>
+          <a:prstGeom prst="rect">
+            <a:avLst/>
+          </a:prstGeom>
+          <a:noFill/>
+        </p:spPr>
+        <p:txBody>
+          <a:bodyPr wrap="square">
+            <a:spAutoFit/>
+          </a:bodyPr>
+          <a:lstStyle/>
+          <a:p>
+            <a:pPr>
+              <a:spcAft>
+                <a:spcPts val="800"/>
+              </a:spcAft>
+            </a:pPr>
+            <a:r>
+              <a:rPr sz="1900" b="1">
+                <a:solidFill>
+                  <a:srgbClr val="0F6CBD"/>
+                </a:solidFill>
+              </a:rPr>
+              <a:t>•  </a:t>
+            </a:r>
+            <a:r>
+              <a:rPr sz="1900" b="0">
+                <a:solidFill>
+                  <a:srgbClr val="0B1F3A"/>
+                </a:solidFill>
+              </a:rPr>
+              <a:t>La sotto-segnalazione al Sud è un'</a:t>
+            </a:r>
+            <a:r>
+              <a:rPr sz="1900" b="1">
+                <a:solidFill>
+                  <a:srgbClr val="0B1F3A"/>
+                </a:solidFill>
+              </a:rPr>
+              <a:t>ipotesi</a:t>
+            </a:r>
+            <a:r>
+              <a:rPr sz="1900" b="0">
+                <a:solidFill>
+                  <a:srgbClr val="0B1F3A"/>
+                </a:solidFill>
+              </a:rPr>
+              <a:t>: serve una verifica sul campo.</a:t>
+            </a:r>
+          </a:p>
+          <a:p>
+            <a:pPr>
+              <a:spcAft>
+                <a:spcPts val="800"/>
+              </a:spcAft>
+            </a:pPr>
+            <a:r>
+              <a:rPr sz="1900" b="1">
+                <a:solidFill>
+                  <a:srgbClr val="0F6CBD"/>
+                </a:solidFill>
+              </a:rPr>
+              <a:t>•  </a:t>
+            </a:r>
+            <a:r>
+              <a:rPr sz="1900" b="0">
+                <a:solidFill>
+                  <a:srgbClr val="0B1F3A"/>
+                </a:solidFill>
+              </a:rPr>
+              <a:t>Al Nord e al Centro un guasto su quattro arriva </a:t>
+            </a:r>
+            <a:r>
+              <a:rPr sz="1900" b="1">
+                <a:solidFill>
+                  <a:srgbClr val="0B1F3A"/>
+                </a:solidFill>
+              </a:rPr>
+              <a:t>senza segnali nei sensori</a:t>
+            </a:r>
+            <a:r>
+              <a:rPr sz="1900" b="0">
+                <a:solidFill>
+                  <a:srgbClr val="0B1F3A"/>
+                </a:solidFill>
+              </a:rPr>
+              <a:t>.</a:t>
+            </a:r>
+          </a:p>
+          <a:p>
+            <a:pPr>
+              <a:spcAft>
+                <a:spcPts val="800"/>
+              </a:spcAft>
+            </a:pPr>
+            <a:r>
+              <a:rPr sz="1900" b="1">
+                <a:solidFill>
+                  <a:srgbClr val="0F6CBD"/>
+                </a:solidFill>
+              </a:rPr>
+              <a:t>•  </a:t>
+            </a:r>
+            <a:r>
+              <a:rPr sz="1900" b="1">
+                <a:solidFill>
+                  <a:srgbClr val="0B1F3A"/>
+                </a:solidFill>
+              </a:rPr>
+              <a:t>183 ispezioni inutili</a:t>
+            </a:r>
+            <a:r>
+              <a:rPr sz="1900" b="0">
+                <a:solidFill>
+                  <a:srgbClr val="0B1F3A"/>
+                </a:solidFill>
+              </a:rPr>
+              <a:t> su 720: il prezzo di un recall più alto; costo 10:1 ipotizzato.</a:t>
+            </a:r>
+          </a:p>
+          <a:p>
+            <a:pPr>
+              <a:spcAft>
+                <a:spcPts val="800"/>
+              </a:spcAft>
+            </a:pPr>
+            <a:r>
+              <a:rPr sz="1900" b="1">
+                <a:solidFill>
+                  <a:srgbClr val="0F6CBD"/>
+                </a:solidFill>
+              </a:rPr>
+              <a:t>•  </a:t>
+            </a:r>
+            <a:r>
+              <a:rPr sz="1900" b="0">
+                <a:solidFill>
+                  <a:srgbClr val="0B1F3A"/>
+                </a:solidFill>
+              </a:rPr>
+              <a:t>La correzione del bias è affidata all'</a:t>
+            </a:r>
+            <a:r>
+              <a:rPr sz="1900" b="1">
+                <a:solidFill>
+                  <a:srgbClr val="0B1F3A"/>
+                </a:solidFill>
+              </a:rPr>
+              <a:t>umano</a:t>
+            </a:r>
+            <a:r>
+              <a:rPr sz="1900" b="0">
+                <a:solidFill>
+                  <a:srgbClr val="0B1F3A"/>
+                </a:solidFill>
+              </a:rPr>
+              <a:t>: se approva tutto, la promozione a HITL serve a poco.</a:t>
+            </a:r>
+          </a:p>
+          <a:p>
+            <a:pPr>
+              <a:spcAft>
+                <a:spcPts val="800"/>
+              </a:spcAft>
+            </a:pPr>
+            <a:r>
+              <a:rPr sz="1900" b="1">
+                <a:solidFill>
+                  <a:srgbClr val="0F6CBD"/>
+                </a:solidFill>
+              </a:rPr>
+              <a:t>•  </a:t>
+            </a:r>
+            <a:r>
+              <a:rPr sz="1900" b="1">
+                <a:solidFill>
+                  <a:srgbClr val="0B1F3A"/>
+                </a:solidFill>
+              </a:rPr>
+              <a:t>Confidenza = max(p, 1−p)</a:t>
+            </a:r>
+            <a:r>
+              <a:rPr sz="1900" b="0">
+                <a:solidFill>
+                  <a:srgbClr val="0B1F3A"/>
+                </a:solidFill>
+              </a:rPr>
+              <a:t>: non aggiunge informazione rispetto alla probabilità.</a:t>
+            </a:r>
+          </a:p>
+          <a:p>
+            <a:pPr>
+              <a:spcAft>
+                <a:spcPts val="800"/>
+              </a:spcAft>
+            </a:pPr>
+            <a:r>
+              <a:rPr sz="1900" b="1">
+                <a:solidFill>
+                  <a:srgbClr val="0F6CBD"/>
+                </a:solidFill>
+              </a:rPr>
+              <a:t>•  </a:t>
+            </a:r>
+            <a:r>
+              <a:rPr sz="1900" b="1">
+                <a:solidFill>
+                  <a:srgbClr val="0B1F3A"/>
+                </a:solidFill>
+              </a:rPr>
+              <a:t>Drift simulato</a:t>
+            </a:r>
+            <a:r>
+              <a:rPr sz="1900" b="0">
+                <a:solidFill>
+                  <a:srgbClr val="0B1F3A"/>
+                </a:solidFill>
+              </a:rPr>
+              <a:t>, revisori non differenziati per competenza, </a:t>
+            </a:r>
+            <a:r>
+              <a:rPr sz="1900" b="1">
+                <a:solidFill>
+                  <a:srgbClr val="0B1F3A"/>
+                </a:solidFill>
+              </a:rPr>
+              <a:t>2 guasti</a:t>
+            </a:r>
+            <a:r>
+              <a:rPr sz="1900" b="0">
+                <a:solidFill>
+                  <a:srgbClr val="0B1F3A"/>
+                </a:solidFill>
+              </a:rPr>
+              <a:t> nelle Isole ancora automatici.</a:t>
+            </a:r>
+          </a:p>
+          <a:p>
+            <a:pPr>
+              <a:spcAft>
+                <a:spcPts val="800"/>
+              </a:spcAft>
+            </a:pPr>
+            <a:r>
+              <a:rPr sz="1900" b="1">
+                <a:solidFill>
+                  <a:srgbClr val="0F6CBD"/>
+                </a:solidFill>
+              </a:rPr>
+              <a:t>•  </a:t>
+            </a:r>
+            <a:r>
+              <a:rPr sz="1900" b="0">
+                <a:solidFill>
+                  <a:srgbClr val="0B1F3A"/>
+                </a:solidFill>
+              </a:rPr>
+              <a:t>Catena di hash </a:t>
+            </a:r>
+            <a:r>
+              <a:rPr sz="1900" b="1">
+                <a:solidFill>
+                  <a:srgbClr val="0B1F3A"/>
+                </a:solidFill>
+              </a:rPr>
+              <a:t>senza chiave</a:t>
+            </a:r>
+            <a:r>
+              <a:rPr sz="1900" b="0">
+                <a:solidFill>
+                  <a:srgbClr val="0B1F3A"/>
+                </a:solidFill>
+              </a:rPr>
+              <a:t>: una riscrittura completa del log non verrebbe rilevata.</a:t>
+            </a:r>
+          </a:p>
+        </p:txBody>
+      </p:sp>
+    </p:spTree>
+  </p:cSld>
+  <p:clrMapOvr>
+    <a:masterClrMapping/>
+  </p:clrMapOvr>
+</p:sld>
+</file>
+
+<file path=ppt/slides/slide15.xml><?xml version="1.0" encoding="utf-8"?>
+<p:sld xmlns:a="http://schemas.openxmlformats.org/drawingml/2006/main" xmlns:p="http://schemas.openxmlformats.org/presentationml/2006/main" xmlns:r="http://schemas.openxmlformats.org/officeDocument/2006/relationships">
+  <p:cSld>
+    <p:spTree>
+      <p:nvGrpSpPr>
+        <p:cNvPr id="1" name=""/>
+        <p:cNvGrpSpPr/>
+        <p:nvPr/>
+      </p:nvGrpSpPr>
+      <p:grpSpPr/>
+      <p:sp>
+        <p:nvSpPr>
+          <p:cNvPr id="2" name="Rectangle 1"/>
+          <p:cNvSpPr/>
+          <p:nvPr/>
+        </p:nvSpPr>
+        <p:spPr>
+          <a:xfrm>
+            <a:off x="0" y="0"/>
+            <a:ext cx="12191695" cy="914400"/>
+          </a:xfrm>
+          <a:prstGeom prst="rect">
+            <a:avLst/>
+          </a:prstGeom>
+          <a:solidFill>
+            <a:srgbClr val="0B1F3A"/>
+          </a:solidFill>
+          <a:ln>
+            <a:noFill/>
+          </a:ln>
+        </p:spPr>
+        <p:style>
+          <a:lnRef idx="1">
+            <a:schemeClr val="accent1"/>
+          </a:lnRef>
+          <a:fillRef idx="3">
+            <a:schemeClr val="accent1"/>
+          </a:fillRef>
+          <a:effectRef idx="2">
+            <a:schemeClr val="accent1"/>
+          </a:effectRef>
+          <a:fontRef idx="minor">
+            <a:schemeClr val="lt1"/>
+          </a:fontRef>
+        </p:style>
+        <p:txBody>
+          <a:bodyPr rtlCol="0" anchor="ctr"/>
+          <a:lstStyle/>
+          <a:p>
+            <a:pPr algn="ctr"/>
+          </a:p>
+        </p:txBody>
+      </p:sp>
+      <p:sp>
+        <p:nvSpPr>
+          <p:cNvPr id="3" name="TextBox 2"/>
+          <p:cNvSpPr txBox="1"/>
+          <p:nvPr/>
+        </p:nvSpPr>
+        <p:spPr>
+          <a:xfrm>
+            <a:off x="457200" y="164592"/>
+            <a:ext cx="9601200" cy="640080"/>
+          </a:xfrm>
+          <a:prstGeom prst="rect">
+            <a:avLst/>
+          </a:prstGeom>
+          <a:noFill/>
+        </p:spPr>
+        <p:txBody>
+          <a:bodyPr wrap="square">
+            <a:spAutoFit/>
+          </a:bodyPr>
+          <a:lstStyle/>
+          <a:p>
+            <a:pPr>
+              <a:spcAft>
+                <a:spcPts val="800"/>
+              </a:spcAft>
+            </a:pPr>
+            <a:r>
+              <a:rPr sz="2800" b="1">
+                <a:solidFill>
+                  <a:srgbClr val="FFFFFF"/>
+                </a:solidFill>
+              </a:rPr>
+              <a:t>AI Act: ruoli e domande aperte</a:t>
+            </a:r>
+          </a:p>
+        </p:txBody>
+      </p:sp>
+      <p:sp>
+        <p:nvSpPr>
+          <p:cNvPr id="4" name="TextBox 3"/>
+          <p:cNvSpPr txBox="1"/>
+          <p:nvPr/>
+        </p:nvSpPr>
+        <p:spPr>
+          <a:xfrm>
+            <a:off x="9418320" y="274320"/>
+            <a:ext cx="2560320" cy="457200"/>
+          </a:xfrm>
+          <a:prstGeom prst="rect">
+            <a:avLst/>
+          </a:prstGeom>
+          <a:noFill/>
+        </p:spPr>
+        <p:txBody>
+          <a:bodyPr wrap="square">
+            <a:spAutoFit/>
+          </a:bodyPr>
+          <a:lstStyle/>
+          <a:p>
+            <a:pPr algn="r">
+              <a:spcAft>
+                <a:spcPts val="800"/>
+              </a:spcAft>
+            </a:pPr>
+            <a:r>
+              <a:rPr sz="1300" b="0">
+                <a:solidFill>
+                  <a:srgbClr val="C9D8EA"/>
+                </a:solidFill>
+              </a:rPr>
+              <a:t>Discussione</a:t>
+            </a:r>
+          </a:p>
+        </p:txBody>
+      </p:sp>
+      <p:sp>
+        <p:nvSpPr>
+          <p:cNvPr id="5" name="Rectangle 4"/>
+          <p:cNvSpPr/>
+          <p:nvPr/>
+        </p:nvSpPr>
+        <p:spPr>
+          <a:xfrm>
+            <a:off x="0" y="914400"/>
+            <a:ext cx="12191695" cy="54864"/>
+          </a:xfrm>
+          <a:prstGeom prst="rect">
+            <a:avLst/>
+          </a:prstGeom>
+          <a:solidFill>
+            <a:srgbClr val="0F6CBD"/>
+          </a:solidFill>
+          <a:ln>
+            <a:noFill/>
+          </a:ln>
+        </p:spPr>
+        <p:style>
+          <a:lnRef idx="1">
+            <a:schemeClr val="accent1"/>
+          </a:lnRef>
+          <a:fillRef idx="3">
+            <a:schemeClr val="accent1"/>
+          </a:fillRef>
+          <a:effectRef idx="2">
+            <a:schemeClr val="accent1"/>
+          </a:effectRef>
+          <a:fontRef idx="minor">
+            <a:schemeClr val="lt1"/>
+          </a:fontRef>
+        </p:style>
+        <p:txBody>
+          <a:bodyPr rtlCol="0" anchor="ctr"/>
+          <a:lstStyle/>
+          <a:p>
+            <a:pPr algn="ctr"/>
+          </a:p>
+        </p:txBody>
+      </p:sp>
+      <p:sp>
+        <p:nvSpPr>
+          <p:cNvPr id="6" name="TextBox 5"/>
+          <p:cNvSpPr txBox="1"/>
+          <p:nvPr/>
+        </p:nvSpPr>
+        <p:spPr>
+          <a:xfrm>
+            <a:off x="548640" y="1280160"/>
             <a:ext cx="5394960" cy="5303520"/>
           </a:xfrm>
           <a:prstGeom prst="rect">
@@ -6890,7 +7377,7 @@
 </p:sld>
 </file>
 
-<file path=ppt/slides/slide15.xml><?xml version="1.0" encoding="utf-8"?>
+<file path=ppt/slides/slide16.xml><?xml version="1.0" encoding="utf-8"?>
 <p:sld xmlns:a="http://schemas.openxmlformats.org/drawingml/2006/main" xmlns:p="http://schemas.openxmlformats.org/presentationml/2006/main" xmlns:r="http://schemas.openxmlformats.org/officeDocument/2006/relationships">
   <p:cSld>
     <p:spTree>

</xml_diff>

<commit_message>
docs(consegna): fix calibration chart and Nord wording in slides
</commit_message>
<xml_diff>
--- a/consegna/EnerGuard_Presentazione.pptx
+++ b/consegna/EnerGuard_Presentazione.pptx
@@ -6727,28 +6727,28 @@
               </a:spcAft>
             </a:pPr>
             <a:r>
-              <a:rPr sz="1400" b="0">
+              <a:rPr sz="1200" b="0">
                 <a:solidFill>
                   <a:srgbClr val="555F6D"/>
                 </a:solidFill>
               </a:rPr>
-              <a:t>Grigio: guasti che il sistema si aspetta guardando i sensori. Colore: guasti registrati. </a:t>
-            </a:r>
-            <a:r>
-              <a:rPr sz="1400" b="1">
+              <a:t>Il sistema è tarato per non perdere guasti, quindi </a:t>
+            </a:r>
+            <a:r>
+              <a:rPr sz="1200" b="1">
                 <a:solidFill>
                   <a:srgbClr val="555F6D"/>
                 </a:solidFill>
               </a:rPr>
-              <a:t>Solo al Sud</a:t>
-            </a:r>
-            <a:r>
-              <a:rPr sz="1400" b="0">
+              <a:t>ne aspetta un po' di più ovunque</a:t>
+            </a:r>
+            <a:r>
+              <a:rPr sz="1200" b="0">
                 <a:solidFill>
                   <a:srgbClr val="555F6D"/>
                 </a:solidFill>
               </a:rPr>
-              <a:t> la differenza è grande (42 contro 24): è il segnale che fa scattare l'allarme.</a:t>
+              <a:t> (media 71 registrati ogni 100 attesi). Il Sud è il più basso (57) ed è la zona con la differenza più grande in numero di guasti (42 attesi, 24 registrati): è questo che fa scattare l'allarme. Il Nord però non è lontano (60): lo dichiariamo tra i limiti.</a:t>
             </a:r>
           </a:p>
         </p:txBody>
@@ -10059,7 +10059,7 @@
                   <a:srgbClr val="0B1F3A"/>
                 </a:solidFill>
               </a:rPr>
-              <a:t>È la spiegazione più probabile, ma va verificata con chi registra i guasti sul territorio.</a:t>
+              <a:t>Va verificata sul territorio. E l'allarme guarda la differenza in numero di guasti: in proporzione anche il Nord registra meno del previsto.</a:t>
             </a:r>
           </a:p>
         </p:txBody>
@@ -14664,7 +14664,7 @@
                   <a:srgbClr val="0B1F3A"/>
                 </a:solidFill>
               </a:rPr>
-              <a:t>Qui i dati sono </a:t>
+              <a:t>Qui il problema principale non sembra nei dati: il sistema, semmai, dà </a:t>
             </a:r>
             <a:r>
               <a:rPr sz="1600" b="1">
@@ -14672,7 +14672,7 @@
                   <a:srgbClr val="0B1F3A"/>
                 </a:solidFill>
               </a:rPr>
-              <a:t>coerenti</a:t>
+              <a:t>allarmi in più</a:t>
             </a:r>
             <a:r>
               <a:rPr sz="1600" b="0">
@@ -14680,7 +14680,7 @@
                   <a:srgbClr val="0B1F3A"/>
                 </a:solidFill>
               </a:rPr>
-              <a:t>: il sistema si aspetta più o meno i guasti che vengono registrati.</a:t>
+              <a:t> (40 su 272 impianti sani), come fa un po' ovunque per non perdere guasti.</a:t>
             </a:r>
           </a:p>
           <a:p>
@@ -14703,7 +14703,7 @@
                   <a:srgbClr val="0B1F3A"/>
                 </a:solidFill>
               </a:rPr>
-              <a:t>Il problema è un altro: circa </a:t>
+              <a:t>Ma su </a:t>
             </a:r>
             <a:r>
               <a:rPr sz="1600" b="1">
@@ -14711,7 +14711,7 @@
                   <a:srgbClr val="0B1F3A"/>
                 </a:solidFill>
               </a:rPr>
-              <a:t>1 guasto su 4 arriva senza preavviso</a:t>
+              <a:t>28 guasti veri ne perde 8</a:t>
             </a:r>
             <a:r>
               <a:rPr sz="1600" b="0">
@@ -14719,7 +14719,7 @@
                   <a:srgbClr val="0B1F3A"/>
                 </a:solidFill>
               </a:rPr>
-              <a:t>. I sensori non mostrano niente di strano: la vibrazione dei guasti persi è più vicina a quella di un impianto sano che a quella dei guasti visti.</a:t>
+              <a:t>: arrivano senza preavviso. I sensori non mostrano niente di strano: la vibrazione dei guasti persi è più vicina a quella di un impianto sano che a quella dei guasti visti.</a:t>
             </a:r>
           </a:p>
           <a:p>
@@ -14742,7 +14742,23 @@
                   <a:srgbClr val="0B1F3A"/>
                 </a:solidFill>
               </a:rPr>
-              <a:t>Nessun sistema può vedere quello che i sensori non misurano.</a:t>
+              <a:t>Quindi sbaglia </a:t>
+            </a:r>
+            <a:r>
+              <a:rPr sz="1600" b="1">
+                <a:solidFill>
+                  <a:srgbClr val="0B1F3A"/>
+                </a:solidFill>
+              </a:rPr>
+              <a:t>in tutte e due le direzioni</a:t>
+            </a:r>
+            <a:r>
+              <a:rPr sz="1600" b="0">
+                <a:solidFill>
+                  <a:srgbClr val="0B1F3A"/>
+                </a:solidFill>
+              </a:rPr>
+              <a:t>: troppi allarmi sugli impianti sani, silenzio sui guasti "muti". Nessun sistema può vedere quello che i sensori non misurano.</a:t>
             </a:r>
           </a:p>
           <a:p>

</xml_diff>